<commit_message>
new file:   SimpliLearn Mock Teach Session/Lesson_05_TensorFlow.pdf 	modified:   SimpliLearn Mock Teach Session/ken_wood_intro.pdf 	modified:   SimpliLearn Mock Teach Session/ken_wood_intro.pptx
</commit_message>
<xml_diff>
--- a/SimpliLearn Mock Teach Session/ken_wood_intro.pptx
+++ b/SimpliLearn Mock Teach Session/ken_wood_intro.pptx
@@ -253,7 +253,7 @@
           <a:p>
             <a:fld id="{48A87A34-81AB-432B-8DAE-1953F412C126}" type="datetimeFigureOut">
               <a:rPr lang="en-US" dirty="0"/>
-              <a:t>2/25/26</a:t>
+              <a:t>2/27/26</a:t>
             </a:fld>
             <a:endParaRPr lang="en-US" dirty="0"/>
           </a:p>
@@ -459,7 +459,7 @@
           <a:p>
             <a:fld id="{48A87A34-81AB-432B-8DAE-1953F412C126}" type="datetimeFigureOut">
               <a:rPr lang="en-US" dirty="0"/>
-              <a:t>2/25/26</a:t>
+              <a:t>2/27/26</a:t>
             </a:fld>
             <a:endParaRPr lang="en-US" dirty="0"/>
           </a:p>
@@ -669,7 +669,7 @@
           <a:p>
             <a:fld id="{48A87A34-81AB-432B-8DAE-1953F412C126}" type="datetimeFigureOut">
               <a:rPr lang="en-US" dirty="0"/>
-              <a:t>2/25/26</a:t>
+              <a:t>2/27/26</a:t>
             </a:fld>
             <a:endParaRPr lang="en-US" dirty="0"/>
           </a:p>
@@ -865,7 +865,7 @@
           <a:p>
             <a:fld id="{48A87A34-81AB-432B-8DAE-1953F412C126}" type="datetimeFigureOut">
               <a:rPr lang="en-US" dirty="0"/>
-              <a:t>2/25/26</a:t>
+              <a:t>2/27/26</a:t>
             </a:fld>
             <a:endParaRPr lang="en-US" dirty="0"/>
           </a:p>
@@ -1139,7 +1139,7 @@
           <a:p>
             <a:fld id="{48A87A34-81AB-432B-8DAE-1953F412C126}" type="datetimeFigureOut">
               <a:rPr lang="en-US" dirty="0"/>
-              <a:t>2/25/26</a:t>
+              <a:t>2/27/26</a:t>
             </a:fld>
             <a:endParaRPr lang="en-US" dirty="0"/>
           </a:p>
@@ -1402,7 +1402,7 @@
           <a:p>
             <a:fld id="{48A87A34-81AB-432B-8DAE-1953F412C126}" type="datetimeFigureOut">
               <a:rPr lang="en-US" dirty="0"/>
-              <a:t>2/25/26</a:t>
+              <a:t>2/27/26</a:t>
             </a:fld>
             <a:endParaRPr lang="en-US" dirty="0"/>
           </a:p>
@@ -1813,7 +1813,7 @@
           <a:p>
             <a:fld id="{48A87A34-81AB-432B-8DAE-1953F412C126}" type="datetimeFigureOut">
               <a:rPr lang="en-US" dirty="0"/>
-              <a:t>2/25/26</a:t>
+              <a:t>2/27/26</a:t>
             </a:fld>
             <a:endParaRPr lang="en-US" dirty="0"/>
           </a:p>
@@ -1957,7 +1957,7 @@
           <a:p>
             <a:fld id="{48A87A34-81AB-432B-8DAE-1953F412C126}" type="datetimeFigureOut">
               <a:rPr lang="en-US" dirty="0"/>
-              <a:t>2/25/26</a:t>
+              <a:t>2/27/26</a:t>
             </a:fld>
             <a:endParaRPr lang="en-US" dirty="0"/>
           </a:p>
@@ -2078,7 +2078,7 @@
           <a:p>
             <a:fld id="{48A87A34-81AB-432B-8DAE-1953F412C126}" type="datetimeFigureOut">
               <a:rPr lang="en-US" dirty="0"/>
-              <a:t>2/25/26</a:t>
+              <a:t>2/27/26</a:t>
             </a:fld>
             <a:endParaRPr lang="en-US" dirty="0"/>
           </a:p>
@@ -2324,7 +2324,7 @@
           <a:p>
             <a:fld id="{48A87A34-81AB-432B-8DAE-1953F412C126}" type="datetimeFigureOut">
               <a:rPr lang="en-US" dirty="0"/>
-              <a:t>2/25/26</a:t>
+              <a:t>2/27/26</a:t>
             </a:fld>
             <a:endParaRPr lang="en-US" dirty="0"/>
           </a:p>
@@ -2765,7 +2765,7 @@
             <a:fld id="{48A87A34-81AB-432B-8DAE-1953F412C126}" type="datetimeFigureOut">
               <a:rPr lang="en-US" dirty="0"/>
               <a:pPr/>
-              <a:t>2/25/26</a:t>
+              <a:t>2/27/26</a:t>
             </a:fld>
             <a:endParaRPr lang="en-US" dirty="0"/>
           </a:p>
@@ -3095,7 +3095,7 @@
             <a:fld id="{48A87A34-81AB-432B-8DAE-1953F412C126}" type="datetimeFigureOut">
               <a:rPr lang="en-US" dirty="0"/>
               <a:pPr/>
-              <a:t>2/25/26</a:t>
+              <a:t>2/27/26</a:t>
             </a:fld>
             <a:endParaRPr lang="en-US" dirty="0"/>
           </a:p>
@@ -4413,7 +4413,7 @@
         <p:spPr/>
         <p:txBody>
           <a:bodyPr>
-            <a:normAutofit fontScale="92500" lnSpcReduction="20000"/>
+            <a:normAutofit lnSpcReduction="10000"/>
           </a:bodyPr>
           <a:lstStyle/>
           <a:p>
@@ -4448,12 +4448,6 @@
             <a:r>
               <a:rPr lang="en-US" dirty="0"/>
               <a:t>)</a:t>
-            </a:r>
-          </a:p>
-          <a:p>
-            <a:r>
-              <a:rPr lang="en-US" dirty="0"/>
-              <a:t>Dimensions and shape compatibility</a:t>
             </a:r>
           </a:p>
           <a:p>
@@ -4498,10 +4492,17 @@
               <a:buChar char="o"/>
             </a:pPr>
             <a:r>
-              <a:rPr lang="en-US"/>
-              <a:t>Trainable parameters</a:t>
-            </a:r>
-            <a:endParaRPr lang="en-US" dirty="0"/>
+              <a:rPr lang="en-US" dirty="0"/>
+              <a:t>Trainable parameters (</a:t>
+            </a:r>
+            <a:r>
+              <a:rPr lang="en-US" dirty="0" err="1"/>
+              <a:t>Wx</a:t>
+            </a:r>
+            <a:r>
+              <a:rPr lang="en-US" dirty="0"/>
+              <a:t> + b)  weights, bias</a:t>
+            </a:r>
           </a:p>
           <a:p>
             <a:endParaRPr lang="en-US" dirty="0"/>

</xml_diff>